<commit_message>
Ablauf angepast in präsentation
</commit_message>
<xml_diff>
--- a/Dokumentation/MinecraftWikiPPTX.pptx
+++ b/Dokumentation/MinecraftWikiPPTX.pptx
@@ -709,7 +709,7 @@
           <a:p>
             <a:fld id="{426D9DD8-02BC-4DB7-B292-89D2677F1421}" type="datetimeFigureOut">
               <a:rPr lang="de-CH" smtClean="0"/>
-              <a:t>13.06.2026</a:t>
+              <a:t>14.06.2026</a:t>
             </a:fld>
             <a:endParaRPr lang="de-CH"/>
           </a:p>
@@ -909,7 +909,7 @@
           <a:p>
             <a:fld id="{426D9DD8-02BC-4DB7-B292-89D2677F1421}" type="datetimeFigureOut">
               <a:rPr lang="de-CH" smtClean="0"/>
-              <a:t>13.06.2026</a:t>
+              <a:t>14.06.2026</a:t>
             </a:fld>
             <a:endParaRPr lang="de-CH"/>
           </a:p>
@@ -1119,7 +1119,7 @@
           <a:p>
             <a:fld id="{426D9DD8-02BC-4DB7-B292-89D2677F1421}" type="datetimeFigureOut">
               <a:rPr lang="de-CH" smtClean="0"/>
-              <a:t>13.06.2026</a:t>
+              <a:t>14.06.2026</a:t>
             </a:fld>
             <a:endParaRPr lang="de-CH"/>
           </a:p>
@@ -1319,7 +1319,7 @@
           <a:p>
             <a:fld id="{426D9DD8-02BC-4DB7-B292-89D2677F1421}" type="datetimeFigureOut">
               <a:rPr lang="de-CH" smtClean="0"/>
-              <a:t>13.06.2026</a:t>
+              <a:t>14.06.2026</a:t>
             </a:fld>
             <a:endParaRPr lang="de-CH"/>
           </a:p>
@@ -1595,7 +1595,7 @@
           <a:p>
             <a:fld id="{426D9DD8-02BC-4DB7-B292-89D2677F1421}" type="datetimeFigureOut">
               <a:rPr lang="de-CH" smtClean="0"/>
-              <a:t>13.06.2026</a:t>
+              <a:t>14.06.2026</a:t>
             </a:fld>
             <a:endParaRPr lang="de-CH"/>
           </a:p>
@@ -1863,7 +1863,7 @@
           <a:p>
             <a:fld id="{426D9DD8-02BC-4DB7-B292-89D2677F1421}" type="datetimeFigureOut">
               <a:rPr lang="de-CH" smtClean="0"/>
-              <a:t>13.06.2026</a:t>
+              <a:t>14.06.2026</a:t>
             </a:fld>
             <a:endParaRPr lang="de-CH"/>
           </a:p>
@@ -2278,7 +2278,7 @@
           <a:p>
             <a:fld id="{426D9DD8-02BC-4DB7-B292-89D2677F1421}" type="datetimeFigureOut">
               <a:rPr lang="de-CH" smtClean="0"/>
-              <a:t>13.06.2026</a:t>
+              <a:t>14.06.2026</a:t>
             </a:fld>
             <a:endParaRPr lang="de-CH"/>
           </a:p>
@@ -2420,7 +2420,7 @@
           <a:p>
             <a:fld id="{426D9DD8-02BC-4DB7-B292-89D2677F1421}" type="datetimeFigureOut">
               <a:rPr lang="de-CH" smtClean="0"/>
-              <a:t>13.06.2026</a:t>
+              <a:t>14.06.2026</a:t>
             </a:fld>
             <a:endParaRPr lang="de-CH"/>
           </a:p>
@@ -2533,7 +2533,7 @@
           <a:p>
             <a:fld id="{426D9DD8-02BC-4DB7-B292-89D2677F1421}" type="datetimeFigureOut">
               <a:rPr lang="de-CH" smtClean="0"/>
-              <a:t>13.06.2026</a:t>
+              <a:t>14.06.2026</a:t>
             </a:fld>
             <a:endParaRPr lang="de-CH"/>
           </a:p>
@@ -2846,7 +2846,7 @@
           <a:p>
             <a:fld id="{426D9DD8-02BC-4DB7-B292-89D2677F1421}" type="datetimeFigureOut">
               <a:rPr lang="de-CH" smtClean="0"/>
-              <a:t>13.06.2026</a:t>
+              <a:t>14.06.2026</a:t>
             </a:fld>
             <a:endParaRPr lang="de-CH"/>
           </a:p>
@@ -3135,7 +3135,7 @@
           <a:p>
             <a:fld id="{426D9DD8-02BC-4DB7-B292-89D2677F1421}" type="datetimeFigureOut">
               <a:rPr lang="de-CH" smtClean="0"/>
-              <a:t>13.06.2026</a:t>
+              <a:t>14.06.2026</a:t>
             </a:fld>
             <a:endParaRPr lang="de-CH"/>
           </a:p>
@@ -3387,7 +3387,7 @@
           <a:p>
             <a:fld id="{426D9DD8-02BC-4DB7-B292-89D2677F1421}" type="datetimeFigureOut">
               <a:rPr lang="de-CH" smtClean="0"/>
-              <a:t>13.06.2026</a:t>
+              <a:t>14.06.2026</a:t>
             </a:fld>
             <a:endParaRPr lang="de-CH"/>
           </a:p>
@@ -3856,7 +3856,7 @@
             </a:extLst>
           </p:cNvPr>
           <p:cNvSpPr>
-            <a:spLocks/>
+            <a:spLocks noGrp="1"/>
           </p:cNvSpPr>
           <p:nvPr>
             <p:ph type="subTitle" idx="1"/>
@@ -5070,7 +5070,7 @@
         </p:spPr>
         <p:txBody>
           <a:bodyPr>
-            <a:normAutofit lnSpcReduction="10000"/>
+            <a:normAutofit fontScale="85000" lnSpcReduction="20000"/>
           </a:bodyPr>
           <a:lstStyle/>
           <a:p>
@@ -5200,6 +5200,45 @@
               </a:rPr>
               <a:t>Auswerten</a:t>
             </a:r>
+          </a:p>
+          <a:p>
+            <a:pPr>
+              <a:buFont typeface="Wingdings" panose="05000000000000000000" pitchFamily="2" charset="2"/>
+              <a:buChar char="§"/>
+            </a:pPr>
+            <a:r>
+              <a:rPr lang="de-CH" sz="2000" dirty="0">
+                <a:solidFill>
+                  <a:schemeClr val="bg1"/>
+                </a:solidFill>
+                <a:latin typeface="Minecraft" panose="02000603000000000000" pitchFamily="2" charset="0"/>
+                <a:ea typeface="Minecraft" panose="02000603000000000000" pitchFamily="2" charset="0"/>
+              </a:rPr>
+              <a:t>Live Demo</a:t>
+            </a:r>
+          </a:p>
+          <a:p>
+            <a:pPr>
+              <a:buFont typeface="Wingdings" panose="05000000000000000000" pitchFamily="2" charset="2"/>
+              <a:buChar char="§"/>
+            </a:pPr>
+            <a:r>
+              <a:rPr lang="de-CH" sz="2000" dirty="0" err="1">
+                <a:solidFill>
+                  <a:schemeClr val="bg1"/>
+                </a:solidFill>
+                <a:latin typeface="Minecraft" panose="02000603000000000000" pitchFamily="2" charset="0"/>
+                <a:ea typeface="Minecraft" panose="02000603000000000000" pitchFamily="2" charset="0"/>
+              </a:rPr>
+              <a:t>Schwirigkeiten</a:t>
+            </a:r>
+            <a:endParaRPr lang="de-CH" sz="2000" dirty="0">
+              <a:solidFill>
+                <a:schemeClr val="bg1"/>
+              </a:solidFill>
+              <a:latin typeface="Minecraft" panose="02000603000000000000" pitchFamily="2" charset="0"/>
+              <a:ea typeface="Minecraft" panose="02000603000000000000" pitchFamily="2" charset="0"/>
+            </a:endParaRPr>
           </a:p>
         </p:txBody>
       </p:sp>

</xml_diff>